<commit_message>
Actualizar slide de Clase 1: agregar progresión localStorage/sessionStorage → memoria servidor → base de datos
Co-Authored-By: Claude Sonnet 5 <noreply@anthropic.com>
</commit_message>
<xml_diff>
--- a/clases/clase-1/presentacion.pptx
+++ b/clases/clase-1/presentacion.pptx
@@ -4022,7 +4022,7 @@
                 <a:ea typeface="Cambria" pitchFamily="34" charset="-122"/>
                 <a:cs typeface="Cambria" pitchFamily="34" charset="-120"/>
               </a:rPr>
-              <a:t>¿Qué pasa si reiniciamos el servidor?</a:t>
+              <a:t>Tres niveles de persistencia</a:t>
             </a:r>
             <a:endParaRPr lang="en-US" sz="2800" dirty="0"/>
           </a:p>
@@ -4065,7 +4065,7 @@
                 <a:ea typeface="Calibri" pitchFamily="34" charset="-122"/>
                 <a:cs typeface="Calibri" pitchFamily="34" charset="-120"/>
               </a:rPr>
-              <a:t>Repaso relámpago: la API Express de la Semana 1 guarda todo en memoria (un array).</a:t>
+              <a:t>Cliente: localStorage/sessionStorage — vive solo en ese navegador, no se comparte entre usuarios.</a:t>
             </a:r>
             <a:endParaRPr lang="en-US" sz="1600" dirty="0"/>
           </a:p>
@@ -4086,7 +4086,7 @@
                 <a:ea typeface="Calibri" pitchFamily="34" charset="-122"/>
                 <a:cs typeface="Calibri" pitchFamily="34" charset="-120"/>
               </a:rPr>
-              <a:t>Pregunta disparadora: si reiniciamos el servidor ahora, ¿qué pasa con los datos creados?</a:t>
+              <a:t>Servidor (Semana 1): memoria del proceso — se comparte entre usuarios, pero es volátil.</a:t>
             </a:r>
             <a:endParaRPr lang="en-US" sz="1600" dirty="0"/>
           </a:p>
@@ -4107,7 +4107,28 @@
                 <a:ea typeface="Calibri" pitchFamily="34" charset="-122"/>
                 <a:cs typeface="Calibri" pitchFamily="34" charset="-120"/>
               </a:rPr>
-              <a:t>Una base de datos resuelve exactamente ese problema: los datos sobreviven al proceso.</a:t>
+              <a:t>Pregunta disparadora: si reiniciamos el servidor ahora, ¿qué pasa con los datos creados?</a:t>
+            </a:r>
+            <a:endParaRPr lang="en-US" sz="1600" dirty="0"/>
+          </a:p>
+          <a:p>
+            <a:pPr marL="342900" indent="-342900">
+              <a:spcAft>
+                <a:spcPts val="1200"/>
+              </a:spcAft>
+              <a:buSzPct val="100000"/>
+              <a:buChar char="•"/>
+            </a:pPr>
+            <a:r>
+              <a:rPr lang="en-US" sz="1600" dirty="0">
+                <a:solidFill>
+                  <a:srgbClr val="1A2E30"/>
+                </a:solidFill>
+                <a:latin typeface="Calibri" pitchFamily="34" charset="0"/>
+                <a:ea typeface="Calibri" pitchFamily="34" charset="-122"/>
+                <a:cs typeface="Calibri" pitchFamily="34" charset="-120"/>
+              </a:rPr>
+              <a:t>Base de datos: los datos sobreviven al proceso — persistencia real, en disco.</a:t>
             </a:r>
             <a:endParaRPr lang="en-US" sz="1600" dirty="0"/>
           </a:p>

</xml_diff>

<commit_message>
Quitar marcas de tiempo de las 5 presentaciones (bloques, ejercicios, preguntas abiertas); corregir bug "EJERCICIO · undefined" en Clase 1 causado por script helper desincronizado
Co-Authored-By: Claude Sonnet 5 <noreply@anthropic.com>
</commit_message>
<xml_diff>
--- a/clases/clase-1/presentacion.pptx
+++ b/clases/clase-1/presentacion.pptx
@@ -2636,7 +2636,7 @@
                 <a:ea typeface="Calibri" pitchFamily="34" charset="-122"/>
                 <a:cs typeface="Calibri" pitchFamily="34" charset="-120"/>
               </a:rPr>
-              <a:t>PREGUNTA ABIERTA 2 · 15’ INVESTIGAN + 10’ PUESTA EN COMÚN</a:t>
+              <a:t>PREGUNTA ABIERTA 2</a:t>
             </a:r>
             <a:endParaRPr lang="en-US" sz="1500" dirty="0"/>
           </a:p>
@@ -2885,8 +2885,8 @@
         </p:nvSpPr>
         <p:spPr>
           <a:xfrm>
-            <a:off x="822960" y="2377440"/>
-            <a:ext cx="1920240" cy="1920240"/>
+            <a:off x="1188720" y="2788920"/>
+            <a:ext cx="1097280" cy="1097280"/>
           </a:xfrm>
           <a:prstGeom prst="ellipse">
             <a:avLst/>
@@ -2910,8 +2910,8 @@
         </p:nvSpPr>
         <p:spPr>
           <a:xfrm>
-            <a:off x="822960" y="2880360"/>
-            <a:ext cx="1920240" cy="914400"/>
+            <a:off x="3200400" y="2423160"/>
+            <a:ext cx="8229600" cy="457200"/>
           </a:xfrm>
           <a:prstGeom prst="rect">
             <a:avLst/>
@@ -2923,105 +2923,66 @@
           <a:bodyPr wrap="square" lIns="0" tIns="0" rIns="0" bIns="0" rtlCol="0" anchor="ctr"/>
           <a:lstStyle/>
           <a:p>
-            <a:pPr algn="ctr" indent="0" marL="0">
+            <a:pPr indent="0" marL="0">
               <a:buNone/>
             </a:pPr>
             <a:r>
-              <a:rPr lang="en-US" sz="3000" b="1" dirty="0">
-                <a:solidFill>
-                  <a:srgbClr val="02C39A"/>
+              <a:rPr lang="en-US" sz="1500" b="1" spc="200" kern="0" dirty="0">
+                <a:solidFill>
+                  <a:srgbClr val="CFEDEA"/>
+                </a:solidFill>
+                <a:latin typeface="Calibri" pitchFamily="34" charset="0"/>
+                <a:ea typeface="Calibri" pitchFamily="34" charset="-122"/>
+                <a:cs typeface="Calibri" pitchFamily="34" charset="-120"/>
+              </a:rPr>
+              <a:t>BLOQUE 4</a:t>
+            </a:r>
+            <a:endParaRPr lang="en-US" sz="1500" dirty="0"/>
+          </a:p>
+        </p:txBody>
+      </p:sp>
+      <p:sp>
+        <p:nvSpPr>
+          <p:cNvPr id="4" name="Text 2"/>
+          <p:cNvSpPr txBox="1"/>
+          <p:nvPr/>
+        </p:nvSpPr>
+        <p:spPr>
+          <a:xfrm>
+            <a:off x="3200400" y="2834640"/>
+            <a:ext cx="8229600" cy="1280160"/>
+          </a:xfrm>
+          <a:prstGeom prst="rect">
+            <a:avLst/>
+          </a:prstGeom>
+          <a:noFill/>
+          <a:ln/>
+        </p:spPr>
+        <p:txBody>
+          <a:bodyPr wrap="square" lIns="0" tIns="0" rIns="0" bIns="0" rtlCol="0" anchor="ctr"/>
+          <a:lstStyle/>
+          <a:p>
+            <a:pPr indent="0" marL="0">
+              <a:buNone/>
+            </a:pPr>
+            <a:r>
+              <a:rPr lang="en-US" sz="3200" b="1" dirty="0">
+                <a:solidFill>
+                  <a:srgbClr val="FFFFFF"/>
                 </a:solidFill>
                 <a:latin typeface="Cambria" pitchFamily="34" charset="0"/>
                 <a:ea typeface="Cambria" pitchFamily="34" charset="-122"/>
                 <a:cs typeface="Cambria" pitchFamily="34" charset="-120"/>
               </a:rPr>
-              <a:t>15’</a:t>
-            </a:r>
-            <a:endParaRPr lang="en-US" sz="3000" dirty="0"/>
-          </a:p>
-        </p:txBody>
-      </p:sp>
-      <p:sp>
-        <p:nvSpPr>
-          <p:cNvPr id="4" name="Text 2"/>
-          <p:cNvSpPr txBox="1"/>
-          <p:nvPr/>
-        </p:nvSpPr>
-        <p:spPr>
-          <a:xfrm>
-            <a:off x="3200400" y="2423160"/>
-            <a:ext cx="8229600" cy="457200"/>
-          </a:xfrm>
-          <a:prstGeom prst="rect">
-            <a:avLst/>
-          </a:prstGeom>
-          <a:noFill/>
-          <a:ln/>
-        </p:spPr>
-        <p:txBody>
-          <a:bodyPr wrap="square" lIns="0" tIns="0" rIns="0" bIns="0" rtlCol="0" anchor="ctr"/>
-          <a:lstStyle/>
-          <a:p>
-            <a:pPr indent="0" marL="0">
-              <a:buNone/>
-            </a:pPr>
-            <a:r>
-              <a:rPr lang="en-US" sz="1500" b="1" spc="200" kern="0" dirty="0">
-                <a:solidFill>
-                  <a:srgbClr val="CFEDEA"/>
-                </a:solidFill>
-                <a:latin typeface="Calibri" pitchFamily="34" charset="0"/>
-                <a:ea typeface="Calibri" pitchFamily="34" charset="-122"/>
-                <a:cs typeface="Calibri" pitchFamily="34" charset="-120"/>
-              </a:rPr>
-              <a:t>BLOQUE 4</a:t>
-            </a:r>
-            <a:endParaRPr lang="en-US" sz="1500" dirty="0"/>
+              <a:t>Buffer de dudas y troubleshooting de setup</a:t>
+            </a:r>
+            <a:endParaRPr lang="en-US" sz="3200" dirty="0"/>
           </a:p>
         </p:txBody>
       </p:sp>
       <p:sp>
         <p:nvSpPr>
           <p:cNvPr id="5" name="Text 3"/>
-          <p:cNvSpPr txBox="1"/>
-          <p:nvPr/>
-        </p:nvSpPr>
-        <p:spPr>
-          <a:xfrm>
-            <a:off x="3200400" y="2834640"/>
-            <a:ext cx="8229600" cy="1280160"/>
-          </a:xfrm>
-          <a:prstGeom prst="rect">
-            <a:avLst/>
-          </a:prstGeom>
-          <a:noFill/>
-          <a:ln/>
-        </p:spPr>
-        <p:txBody>
-          <a:bodyPr wrap="square" lIns="0" tIns="0" rIns="0" bIns="0" rtlCol="0" anchor="ctr"/>
-          <a:lstStyle/>
-          <a:p>
-            <a:pPr indent="0" marL="0">
-              <a:buNone/>
-            </a:pPr>
-            <a:r>
-              <a:rPr lang="en-US" sz="3200" b="1" dirty="0">
-                <a:solidFill>
-                  <a:srgbClr val="FFFFFF"/>
-                </a:solidFill>
-                <a:latin typeface="Cambria" pitchFamily="34" charset="0"/>
-                <a:ea typeface="Cambria" pitchFamily="34" charset="-122"/>
-                <a:cs typeface="Cambria" pitchFamily="34" charset="-120"/>
-              </a:rPr>
-              <a:t>Buffer de dudas y troubleshooting de setup</a:t>
-            </a:r>
-            <a:endParaRPr lang="en-US" sz="3200" dirty="0"/>
-          </a:p>
-        </p:txBody>
-      </p:sp>
-      <p:sp>
-        <p:nvSpPr>
-          <p:cNvPr id="6" name="Text 4"/>
           <p:cNvSpPr txBox="1"/>
           <p:nvPr/>
         </p:nvSpPr>
@@ -3099,7 +3060,7 @@
         <p:spPr>
           <a:xfrm>
             <a:off x="640080" y="502920"/>
-            <a:ext cx="2743200" cy="502920"/>
+            <a:ext cx="1737360" cy="502920"/>
           </a:xfrm>
           <a:prstGeom prst="roundRect">
             <a:avLst>
@@ -3121,7 +3082,7 @@
         <p:spPr>
           <a:xfrm>
             <a:off x="640080" y="502920"/>
-            <a:ext cx="2743200" cy="502920"/>
+            <a:ext cx="1737360" cy="502920"/>
           </a:xfrm>
           <a:prstGeom prst="rect">
             <a:avLst/>
@@ -3145,7 +3106,7 @@
                 <a:ea typeface="Calibri" pitchFamily="34" charset="-122"/>
                 <a:cs typeface="Calibri" pitchFamily="34" charset="-120"/>
               </a:rPr>
-              <a:t>EJERCICIO · 1h40</a:t>
+              <a:t>EJERCICIO</a:t>
             </a:r>
             <a:endParaRPr lang="en-US" sz="1300" dirty="0"/>
           </a:p>
@@ -3803,8 +3764,8 @@
         </p:nvSpPr>
         <p:spPr>
           <a:xfrm>
-            <a:off x="822960" y="2377440"/>
-            <a:ext cx="1920240" cy="1920240"/>
+            <a:off x="1188720" y="2788920"/>
+            <a:ext cx="1097280" cy="1097280"/>
           </a:xfrm>
           <a:prstGeom prst="ellipse">
             <a:avLst/>
@@ -3828,45 +3789,6 @@
         </p:nvSpPr>
         <p:spPr>
           <a:xfrm>
-            <a:off x="822960" y="2880360"/>
-            <a:ext cx="1920240" cy="914400"/>
-          </a:xfrm>
-          <a:prstGeom prst="rect">
-            <a:avLst/>
-          </a:prstGeom>
-          <a:noFill/>
-          <a:ln/>
-        </p:spPr>
-        <p:txBody>
-          <a:bodyPr wrap="square" lIns="0" tIns="0" rIns="0" bIns="0" rtlCol="0" anchor="ctr"/>
-          <a:lstStyle/>
-          <a:p>
-            <a:pPr algn="ctr" indent="0" marL="0">
-              <a:buNone/>
-            </a:pPr>
-            <a:r>
-              <a:rPr lang="en-US" sz="3000" b="1" dirty="0">
-                <a:solidFill>
-                  <a:srgbClr val="02C39A"/>
-                </a:solidFill>
-                <a:latin typeface="Cambria" pitchFamily="34" charset="0"/>
-                <a:ea typeface="Cambria" pitchFamily="34" charset="-122"/>
-                <a:cs typeface="Cambria" pitchFamily="34" charset="-120"/>
-              </a:rPr>
-              <a:t>25’</a:t>
-            </a:r>
-            <a:endParaRPr lang="en-US" sz="3000" dirty="0"/>
-          </a:p>
-        </p:txBody>
-      </p:sp>
-      <p:sp>
-        <p:nvSpPr>
-          <p:cNvPr id="4" name="Text 2"/>
-          <p:cNvSpPr txBox="1"/>
-          <p:nvPr/>
-        </p:nvSpPr>
-        <p:spPr>
-          <a:xfrm>
             <a:off x="3200400" y="2423160"/>
             <a:ext cx="8229600" cy="457200"/>
           </a:xfrm>
@@ -3900,7 +3822,7 @@
       </p:sp>
       <p:sp>
         <p:nvSpPr>
-          <p:cNvPr id="5" name="Text 3"/>
+          <p:cNvPr id="4" name="Text 2"/>
           <p:cNvSpPr txBox="1"/>
           <p:nvPr/>
         </p:nvSpPr>
@@ -4396,7 +4318,7 @@
                 <a:ea typeface="Calibri" pitchFamily="34" charset="-122"/>
                 <a:cs typeface="Calibri" pitchFamily="34" charset="-120"/>
               </a:rPr>
-              <a:t>PREGUNTA ABIERTA 1 · 15’ INVESTIGAN + 10’ PUESTA EN COMÚN</a:t>
+              <a:t>PREGUNTA ABIERTA 1</a:t>
             </a:r>
             <a:endParaRPr lang="en-US" sz="1500" dirty="0"/>
           </a:p>
@@ -4645,8 +4567,8 @@
         </p:nvSpPr>
         <p:spPr>
           <a:xfrm>
-            <a:off x="822960" y="2377440"/>
-            <a:ext cx="1920240" cy="1920240"/>
+            <a:off x="1188720" y="2788920"/>
+            <a:ext cx="1097280" cy="1097280"/>
           </a:xfrm>
           <a:prstGeom prst="ellipse">
             <a:avLst/>
@@ -4670,45 +4592,6 @@
         </p:nvSpPr>
         <p:spPr>
           <a:xfrm>
-            <a:off x="822960" y="2880360"/>
-            <a:ext cx="1920240" cy="914400"/>
-          </a:xfrm>
-          <a:prstGeom prst="rect">
-            <a:avLst/>
-          </a:prstGeom>
-          <a:noFill/>
-          <a:ln/>
-        </p:spPr>
-        <p:txBody>
-          <a:bodyPr wrap="square" lIns="0" tIns="0" rIns="0" bIns="0" rtlCol="0" anchor="ctr"/>
-          <a:lstStyle/>
-          <a:p>
-            <a:pPr algn="ctr" indent="0" marL="0">
-              <a:buNone/>
-            </a:pPr>
-            <a:r>
-              <a:rPr lang="en-US" sz="3000" b="1" dirty="0">
-                <a:solidFill>
-                  <a:srgbClr val="02C39A"/>
-                </a:solidFill>
-                <a:latin typeface="Cambria" pitchFamily="34" charset="0"/>
-                <a:ea typeface="Cambria" pitchFamily="34" charset="-122"/>
-                <a:cs typeface="Cambria" pitchFamily="34" charset="-120"/>
-              </a:rPr>
-              <a:t>30’</a:t>
-            </a:r>
-            <a:endParaRPr lang="en-US" sz="3000" dirty="0"/>
-          </a:p>
-        </p:txBody>
-      </p:sp>
-      <p:sp>
-        <p:nvSpPr>
-          <p:cNvPr id="4" name="Text 2"/>
-          <p:cNvSpPr txBox="1"/>
-          <p:nvPr/>
-        </p:nvSpPr>
-        <p:spPr>
-          <a:xfrm>
             <a:off x="3200400" y="2423160"/>
             <a:ext cx="8229600" cy="457200"/>
           </a:xfrm>
@@ -4742,7 +4625,7 @@
       </p:sp>
       <p:sp>
         <p:nvSpPr>
-          <p:cNvPr id="5" name="Text 3"/>
+          <p:cNvPr id="4" name="Text 2"/>
           <p:cNvSpPr txBox="1"/>
           <p:nvPr/>
         </p:nvSpPr>
@@ -5016,8 +4899,8 @@
         </p:nvSpPr>
         <p:spPr>
           <a:xfrm>
-            <a:off x="822960" y="2377440"/>
-            <a:ext cx="1920240" cy="1920240"/>
+            <a:off x="1188720" y="2788920"/>
+            <a:ext cx="1097280" cy="1097280"/>
           </a:xfrm>
           <a:prstGeom prst="ellipse">
             <a:avLst/>
@@ -5041,45 +4924,6 @@
         </p:nvSpPr>
         <p:spPr>
           <a:xfrm>
-            <a:off x="822960" y="2880360"/>
-            <a:ext cx="1920240" cy="914400"/>
-          </a:xfrm>
-          <a:prstGeom prst="rect">
-            <a:avLst/>
-          </a:prstGeom>
-          <a:noFill/>
-          <a:ln/>
-        </p:spPr>
-        <p:txBody>
-          <a:bodyPr wrap="square" lIns="0" tIns="0" rIns="0" bIns="0" rtlCol="0" anchor="ctr"/>
-          <a:lstStyle/>
-          <a:p>
-            <a:pPr algn="ctr" indent="0" marL="0">
-              <a:buNone/>
-            </a:pPr>
-            <a:r>
-              <a:rPr lang="en-US" sz="3000" b="1" dirty="0">
-                <a:solidFill>
-                  <a:srgbClr val="02C39A"/>
-                </a:solidFill>
-                <a:latin typeface="Cambria" pitchFamily="34" charset="0"/>
-                <a:ea typeface="Cambria" pitchFamily="34" charset="-122"/>
-                <a:cs typeface="Cambria" pitchFamily="34" charset="-120"/>
-              </a:rPr>
-              <a:t>20’</a:t>
-            </a:r>
-            <a:endParaRPr lang="en-US" sz="3000" dirty="0"/>
-          </a:p>
-        </p:txBody>
-      </p:sp>
-      <p:sp>
-        <p:nvSpPr>
-          <p:cNvPr id="4" name="Text 2"/>
-          <p:cNvSpPr txBox="1"/>
-          <p:nvPr/>
-        </p:nvSpPr>
-        <p:spPr>
-          <a:xfrm>
             <a:off x="3200400" y="2423160"/>
             <a:ext cx="8229600" cy="457200"/>
           </a:xfrm>
@@ -5113,7 +4957,7 @@
       </p:sp>
       <p:sp>
         <p:nvSpPr>
-          <p:cNvPr id="5" name="Text 3"/>
+          <p:cNvPr id="4" name="Text 2"/>
           <p:cNvSpPr txBox="1"/>
           <p:nvPr/>
         </p:nvSpPr>

</xml_diff>

<commit_message>
Cambiar herramienta de modelado ER de dbdiagram.io a draw.io, y agregar flujo de entrega vía GitHub (main protegida + PR con review)
Motivo: draw.io no exporta a SQL automáticamente, así que en Clase 2 los alumnos escriben el CREATE TABLE completamente a mano en vez de partir de un export — y el entregable de Clase 1 pasa a ser un PR mergeado, replicando el mismo flujo de Backend Introduction en vez de un link público de la herramienta.

Afecta: setup de Clase 1 (03-drawio.md reemplaza 03-dbdiagram.md), README y guía docente de Clase 1 y 2, referencias, contenido de Telus Academy (MATERIAL 1 + Guía de Ejercicios 1), y las presentaciones de Clase 1 y 2.

Co-Authored-By: Claude Sonnet 5 <noreply@anthropic.com>
</commit_message>
<xml_diff>
--- a/clases/clase-1/presentacion.pptx
+++ b/clases/clase-1/presentacion.pptx
@@ -2334,7 +2334,7 @@
                 <a:ea typeface="Cambria" pitchFamily="34" charset="-122"/>
                 <a:cs typeface="Cambria" pitchFamily="34" charset="-120"/>
               </a:rPr>
-              <a:t>dbdiagram.io</a:t>
+              <a:t>draw.io</a:t>
             </a:r>
             <a:endParaRPr lang="en-US" sz="1800" dirty="0"/>
           </a:p>
@@ -2377,7 +2377,7 @@
                 <a:ea typeface="Calibri" pitchFamily="34" charset="-122"/>
                 <a:cs typeface="Calibri" pitchFamily="34" charset="-120"/>
               </a:rPr>
-              <a:t>Herramienta web, sintaxis simple tipo código.</a:t>
+              <a:t>Herramienta web, dibujás cajas y las conectás con flechas.</a:t>
             </a:r>
             <a:endParaRPr lang="en-US" sz="1400" dirty="0"/>
           </a:p>
@@ -2419,7 +2419,7 @@
                 <a:ea typeface="Calibri" pitchFamily="34" charset="-122"/>
                 <a:cs typeface="Calibri" pitchFamily="34" charset="-120"/>
               </a:rPr>
-              <a:t>Exporta directo a SQL (CREATE TABLE) — lo vamos a usar en Clase 2.</a:t>
+              <a:t>Sin export a SQL a propósito — en Clase 2 escribimos el CREATE TABLE a mano.</a:t>
             </a:r>
             <a:endParaRPr lang="en-US" sz="1400" dirty="0"/>
           </a:p>
@@ -3207,7 +3207,7 @@
                 <a:ea typeface="Calibri" pitchFamily="34" charset="-122"/>
                 <a:cs typeface="Calibri" pitchFamily="34" charset="-120"/>
               </a:rPr>
-              <a:t>2.  Modelá en dbdiagram.io al menos 2 tablas relacionadas entre sí (ej. personajes y casas, o naves y planetas).</a:t>
+              <a:t>2.  Modelá en draw.io al menos 2 tablas relacionadas entre sí (ej. personajes y casas, o naves y planetas).</a:t>
             </a:r>
             <a:endParaRPr lang="en-US" sz="1400" dirty="0"/>
           </a:p>
@@ -3247,46 +3247,66 @@
                 <a:ea typeface="Calibri" pitchFamily="34" charset="-122"/>
                 <a:cs typeface="Calibri" pitchFamily="34" charset="-120"/>
               </a:rPr>
-              <a:t>4.  Si terminás antes: agregá una tercera tabla (relación N a N) y pensá cómo se modelaría con una tabla intermedia.</a:t>
+              <a:t>4.  Exportá el diagrama como imagen y subilo a tu repo vía PR (main protegida, mismo flujo que Backend Introduction).</a:t>
             </a:r>
             <a:endParaRPr lang="en-US" sz="1400" dirty="0"/>
           </a:p>
-        </p:txBody>
-      </p:sp>
-      <p:sp>
-        <p:nvSpPr>
-          <p:cNvPr id="6" name="Text 4"/>
-          <p:cNvSpPr txBox="1"/>
-          <p:nvPr/>
-        </p:nvSpPr>
-        <p:spPr>
-          <a:xfrm>
-            <a:off x="640080" y="6263640"/>
-            <a:ext cx="10698480" cy="365760"/>
-          </a:xfrm>
-          <a:prstGeom prst="rect">
-            <a:avLst/>
-          </a:prstGeom>
-          <a:noFill/>
-          <a:ln/>
-        </p:spPr>
-        <p:txBody>
-          <a:bodyPr wrap="square" lIns="0" tIns="0" rIns="0" bIns="0" rtlCol="0" anchor="ctr"/>
-          <a:lstStyle/>
           <a:p>
             <a:pPr indent="0" marL="0">
+              <a:spcAft>
+                <a:spcPts val="1100"/>
+              </a:spcAft>
               <a:buNone/>
             </a:pPr>
             <a:r>
-              <a:rPr lang="en-US" sz="1200" i="1" dirty="0">
-                <a:solidFill>
-                  <a:srgbClr val="5C6F70"/>
+              <a:rPr lang="en-US" sz="1400" dirty="0">
+                <a:solidFill>
+                  <a:srgbClr val="1A2E30"/>
                 </a:solidFill>
                 <a:latin typeface="Calibri" pitchFamily="34" charset="0"/>
                 <a:ea typeface="Calibri" pitchFamily="34" charset="-122"/>
                 <a:cs typeface="Calibri" pitchFamily="34" charset="-120"/>
               </a:rPr>
-              <a:t>Cierre: 2-3 voluntarios comparten su diagrama y explican sus decisiones.</a:t>
+              <a:t>5.  Si terminás antes: agregá una tercera tabla (relación N a N) y pensá cómo se modelaría con una tabla intermedia.</a:t>
+            </a:r>
+            <a:endParaRPr lang="en-US" sz="1400" dirty="0"/>
+          </a:p>
+        </p:txBody>
+      </p:sp>
+      <p:sp>
+        <p:nvSpPr>
+          <p:cNvPr id="6" name="Text 4"/>
+          <p:cNvSpPr txBox="1"/>
+          <p:nvPr/>
+        </p:nvSpPr>
+        <p:spPr>
+          <a:xfrm>
+            <a:off x="640080" y="6263640"/>
+            <a:ext cx="10698480" cy="365760"/>
+          </a:xfrm>
+          <a:prstGeom prst="rect">
+            <a:avLst/>
+          </a:prstGeom>
+          <a:noFill/>
+          <a:ln/>
+        </p:spPr>
+        <p:txBody>
+          <a:bodyPr wrap="square" lIns="0" tIns="0" rIns="0" bIns="0" rtlCol="0" anchor="ctr"/>
+          <a:lstStyle/>
+          <a:p>
+            <a:pPr indent="0" marL="0">
+              <a:buNone/>
+            </a:pPr>
+            <a:r>
+              <a:rPr lang="en-US" sz="1200" i="1" dirty="0">
+                <a:solidFill>
+                  <a:srgbClr val="5C6F70"/>
+                </a:solidFill>
+                <a:latin typeface="Calibri" pitchFamily="34" charset="0"/>
+                <a:ea typeface="Calibri" pitchFamily="34" charset="-122"/>
+                <a:cs typeface="Calibri" pitchFamily="34" charset="-120"/>
+              </a:rPr>
+              <a:t>Cierre: 2-3 voluntarios comparten su diagrama (desde el PR) y explican sus decisiones.</a:t>
             </a:r>
             <a:endParaRPr lang="en-US" sz="1200" dirty="0"/>
           </a:p>

</xml_diff>